<commit_message>
Update CargoChain shipment tracking and blockchain
</commit_message>
<xml_diff>
--- a/cargochain_sih_pitch.pptx
+++ b/cargochain_sih_pitch.pptx
@@ -6029,16 +6029,8 @@
           </a:bodyPr>
           <a:lstStyle/>
           <a:p>
-            <a:pPr>
-              <a:defRPr sz="3600" b="1">
-                <a:solidFill>
-                  <a:srgbClr val="0D9488"/>
-                </a:solidFill>
-                <a:latin typeface="Segoe UI"/>
-              </a:defRPr>
-            </a:pPr>
-            <a:r>
-              <a:t>Technical Stack (Reflecting CargoChain Codebase)</a:t>
+            <a:r>
+              <a:t>Technical Approach</a:t>
             </a:r>
           </a:p>
         </p:txBody>
@@ -6073,15 +6065,15 @@
                     <a:lstStyle/>
                     <a:p>
                       <a:pPr>
-                        <a:defRPr sz="1400" b="1">
+                        <a:defRPr sz="1300" b="1">
                           <a:solidFill>
-                            <a:srgbClr val="F1F5F9"/>
+                            <a:srgbClr val="FFFFFF"/>
                           </a:solidFill>
                           <a:latin typeface="Segoe UI"/>
                         </a:defRPr>
                       </a:pPr>
                       <a:r>
-                        <a:t>Layer</a:t>
+                        <a:t>Layer / Component</a:t>
                       </a:r>
                     </a:p>
                   </a:txBody>
@@ -6097,15 +6089,15 @@
                     <a:lstStyle/>
                     <a:p>
                       <a:pPr>
-                        <a:defRPr sz="1400" b="1">
+                        <a:defRPr sz="1300" b="1">
                           <a:solidFill>
-                            <a:srgbClr val="F1F5F9"/>
+                            <a:srgbClr val="FFFFFF"/>
                           </a:solidFill>
                           <a:latin typeface="Segoe UI"/>
                         </a:defRPr>
                       </a:pPr>
                       <a:r>
-                        <a:t>Technology Used</a:t>
+                        <a:t>Technology Chosen</a:t>
                       </a:r>
                     </a:p>
                   </a:txBody>
@@ -6121,15 +6113,15 @@
                     <a:lstStyle/>
                     <a:p>
                       <a:pPr>
-                        <a:defRPr sz="1400" b="1">
+                        <a:defRPr sz="1300" b="1">
                           <a:solidFill>
-                            <a:srgbClr val="F1F5F9"/>
+                            <a:srgbClr val="FFFFFF"/>
                           </a:solidFill>
                           <a:latin typeface="Segoe UI"/>
                         </a:defRPr>
                       </a:pPr>
                       <a:r>
-                        <a:t>Role in CargoChain Platform</a:t>
+                        <a:t>Decision Rationale (Why this stack?)</a:t>
                       </a:r>
                     </a:p>
                   </a:txBody>
@@ -6147,15 +6139,15 @@
                     <a:lstStyle/>
                     <a:p>
                       <a:pPr>
-                        <a:defRPr sz="1200" b="1">
+                        <a:defRPr sz="1100" b="0">
                           <a:solidFill>
-                            <a:srgbClr val="0F172A"/>
+                            <a:srgbClr val="DCDCDC"/>
                           </a:solidFill>
                           <a:latin typeface="Segoe UI"/>
                         </a:defRPr>
                       </a:pPr>
                       <a:r>
-                        <a:t>Frontend Application</a:t>
+                        <a:t>ML Prediction Engine</a:t>
                       </a:r>
                     </a:p>
                   </a:txBody>
@@ -6171,15 +6163,15 @@
                     <a:lstStyle/>
                     <a:p>
                       <a:pPr>
-                        <a:defRPr sz="1200">
+                        <a:defRPr sz="1100" b="0">
                           <a:solidFill>
-                            <a:srgbClr val="0F172A"/>
+                            <a:srgbClr val="DCDCDC"/>
                           </a:solidFill>
                           <a:latin typeface="Segoe UI"/>
                         </a:defRPr>
                       </a:pPr>
                       <a:r>
-                        <a:t>React 19, Leaflet, Recharts, Tailwind CSS</a:t>
+                        <a:t>Python + FastAPI (XGBoost)</a:t>
                       </a:r>
                     </a:p>
                   </a:txBody>
@@ -6195,15 +6187,15 @@
                     <a:lstStyle/>
                     <a:p>
                       <a:pPr>
-                        <a:defRPr sz="1200">
+                        <a:defRPr sz="1100" b="0">
                           <a:solidFill>
-                            <a:srgbClr val="0F172A"/>
+                            <a:srgbClr val="DCDCDC"/>
                           </a:solidFill>
                           <a:latin typeface="Segoe UI"/>
                         </a:defRPr>
                       </a:pPr>
                       <a:r>
-                        <a:t>Interactive dashboard displaying real-time shipment map paths, multimodal timeline transitions, and bottleneck charts.</a:t>
+                        <a:t>Mature ML ecosystem in Python. Isolated as a separate microservice so that heavy delay computations do not block or down the main dashboard.</a:t>
                       </a:r>
                     </a:p>
                   </a:txBody>
@@ -6221,9 +6213,9 @@
                     <a:lstStyle/>
                     <a:p>
                       <a:pPr>
-                        <a:defRPr sz="1200" b="1">
+                        <a:defRPr sz="1100" b="0">
                           <a:solidFill>
-                            <a:srgbClr val="0F172A"/>
+                            <a:srgbClr val="DCDCDC"/>
                           </a:solidFill>
                           <a:latin typeface="Segoe UI"/>
                         </a:defRPr>
@@ -6245,15 +6237,15 @@
                     <a:lstStyle/>
                     <a:p>
                       <a:pPr>
-                        <a:defRPr sz="1200">
+                        <a:defRPr sz="1100" b="0">
                           <a:solidFill>
-                            <a:srgbClr val="0F172A"/>
+                            <a:srgbClr val="DCDCDC"/>
                           </a:solidFill>
                           <a:latin typeface="Segoe UI"/>
                         </a:defRPr>
                       </a:pPr>
                       <a:r>
-                        <a:t>Node.js, Express, Socket.io-client</a:t>
+                        <a:t>Node.js + Express + TypeScript</a:t>
                       </a:r>
                     </a:p>
                   </a:txBody>
@@ -6269,15 +6261,15 @@
                     <a:lstStyle/>
                     <a:p>
                       <a:pPr>
-                        <a:defRPr sz="1200">
+                        <a:defRPr sz="1100" b="0">
                           <a:solidFill>
-                            <a:srgbClr val="0F172A"/>
+                            <a:srgbClr val="DCDCDC"/>
                           </a:solidFill>
                           <a:latin typeface="Segoe UI"/>
                         </a:defRPr>
                       </a:pPr>
                       <a:r>
-                        <a:t>Real-time event synchronization (WebSockets) sending delay risk changes and coordination alerts dynamically to operators.</a:t>
+                        <a:t>Asynchronous event-driven model is ideal for handling concurrent real-time events (FASTag, FOIS, PCS1x). TypeScript prevents codebase bugs.</a:t>
                       </a:r>
                     </a:p>
                   </a:txBody>
@@ -6295,15 +6287,15 @@
                     <a:lstStyle/>
                     <a:p>
                       <a:pPr>
-                        <a:defRPr sz="1200" b="1">
+                        <a:defRPr sz="1100" b="0">
                           <a:solidFill>
-                            <a:srgbClr val="0F172A"/>
+                            <a:srgbClr val="DCDCDC"/>
                           </a:solidFill>
                           <a:latin typeface="Segoe UI"/>
                         </a:defRPr>
                       </a:pPr>
                       <a:r>
-                        <a:t>Security Ledger</a:t>
+                        <a:t>Database Layer</a:t>
                       </a:r>
                     </a:p>
                   </a:txBody>
@@ -6319,15 +6311,15 @@
                     <a:lstStyle/>
                     <a:p>
                       <a:pPr>
-                        <a:defRPr sz="1200">
+                        <a:defRPr sz="1100" b="0">
                           <a:solidFill>
-                            <a:srgbClr val="0F172A"/>
+                            <a:srgbClr val="DCDCDC"/>
                           </a:solidFill>
                           <a:latin typeface="Segoe UI"/>
                         </a:defRPr>
                       </a:pPr>
                       <a:r>
-                        <a:t>Custom Blockchain (SHA-256 blocks in JS)</a:t>
+                        <a:t>PostgreSQL + Prisma ORM</a:t>
                       </a:r>
                     </a:p>
                   </a:txBody>
@@ -6343,15 +6335,15 @@
                     <a:lstStyle/>
                     <a:p>
                       <a:pPr>
-                        <a:defRPr sz="1200">
+                        <a:defRPr sz="1100" b="0">
                           <a:solidFill>
-                            <a:srgbClr val="0F172A"/>
+                            <a:srgbClr val="DCDCDC"/>
                           </a:solidFill>
                           <a:latin typeface="Segoe UI"/>
                         </a:defRPr>
                       </a:pPr>
                       <a:r>
-                        <a:t>Provides a transparent, tamper-proof audit trail for cargo handovers (Origin -&gt; Road -&gt; Rail -&gt; Port -&gt; Destination).</a:t>
+                        <a:t>Logistics data is highly relational (1 Shipment -&gt; Multiple Handoff Legs -&gt; Leg predictions). This structures naturally in SQL database.</a:t>
                       </a:r>
                     </a:p>
                   </a:txBody>
@@ -6369,15 +6361,15 @@
                     <a:lstStyle/>
                     <a:p>
                       <a:pPr>
-                        <a:defRPr sz="1200" b="1">
+                        <a:defRPr sz="1100" b="0">
                           <a:solidFill>
-                            <a:srgbClr val="0F172A"/>
+                            <a:srgbClr val="DCDCDC"/>
                           </a:solidFill>
                           <a:latin typeface="Segoe UI"/>
                         </a:defRPr>
                       </a:pPr>
                       <a:r>
-                        <a:t>Prediction Analytics</a:t>
+                        <a:t>Frontend Dashboard</a:t>
                       </a:r>
                     </a:p>
                   </a:txBody>
@@ -6393,15 +6385,15 @@
                     <a:lstStyle/>
                     <a:p>
                       <a:pPr>
-                        <a:defRPr sz="1200">
+                        <a:defRPr sz="1100" b="0">
                           <a:solidFill>
-                            <a:srgbClr val="0F172A"/>
+                            <a:srgbClr val="DCDCDC"/>
                           </a:solidFill>
                           <a:latin typeface="Segoe UI"/>
                         </a:defRPr>
                       </a:pPr>
                       <a:r>
-                        <a:t>Python, Scikit-learn, XGBoost</a:t>
+                        <a:t>React + Leaflet + Chart.js</a:t>
                       </a:r>
                     </a:p>
                   </a:txBody>
@@ -6417,15 +6409,89 @@
                     <a:lstStyle/>
                     <a:p>
                       <a:pPr>
-                        <a:defRPr sz="1200">
+                        <a:defRPr sz="1100" b="0">
                           <a:solidFill>
-                            <a:srgbClr val="0F172A"/>
+                            <a:srgbClr val="DCDCDC"/>
                           </a:solidFill>
                           <a:latin typeface="Segoe UI"/>
                         </a:defRPr>
                       </a:pPr>
                       <a:r>
-                        <a:t>Analyzes historical port dwell time and rail transit delays to compute risk scores for downstream transit legs.</a:t>
+                        <a:t>React provides a reactive dashboard. Leaflet handles the GIS corridor map paths, and Chart.js manages risk-score trend visualizations.</a:t>
+                      </a:r>
+                    </a:p>
+                  </a:txBody>
+                  <a:tcPr>
+                    <a:solidFill>
+                      <a:srgbClr val="FFFFFF"/>
+                    </a:solidFill>
+                  </a:tcPr>
+                </a:tc>
+              </a:tr>
+              <a:tr h="822960">
+                <a:tc>
+                  <a:txBody>
+                    <a:bodyPr/>
+                    <a:lstStyle/>
+                    <a:p>
+                      <a:pPr>
+                        <a:defRPr sz="1100" b="0">
+                          <a:solidFill>
+                            <a:srgbClr val="DCDCDC"/>
+                          </a:solidFill>
+                          <a:latin typeface="Segoe UI"/>
+                        </a:defRPr>
+                      </a:pPr>
+                      <a:r>
+                        <a:t>Orchestration</a:t>
+                      </a:r>
+                    </a:p>
+                  </a:txBody>
+                  <a:tcPr>
+                    <a:solidFill>
+                      <a:srgbClr val="FFFFFF"/>
+                    </a:solidFill>
+                  </a:tcPr>
+                </a:tc>
+                <a:tc>
+                  <a:txBody>
+                    <a:bodyPr/>
+                    <a:lstStyle/>
+                    <a:p>
+                      <a:pPr>
+                        <a:defRPr sz="1100" b="0">
+                          <a:solidFill>
+                            <a:srgbClr val="DCDCDC"/>
+                          </a:solidFill>
+                          <a:latin typeface="Segoe UI"/>
+                        </a:defRPr>
+                      </a:pPr>
+                      <a:r>
+                        <a:t>Docker Compose</a:t>
+                      </a:r>
+                    </a:p>
+                  </a:txBody>
+                  <a:tcPr>
+                    <a:solidFill>
+                      <a:srgbClr val="FFFFFF"/>
+                    </a:solidFill>
+                  </a:tcPr>
+                </a:tc>
+                <a:tc>
+                  <a:txBody>
+                    <a:bodyPr/>
+                    <a:lstStyle/>
+                    <a:p>
+                      <a:pPr>
+                        <a:defRPr sz="1100" b="0">
+                          <a:solidFill>
+                            <a:srgbClr val="DCDCDC"/>
+                          </a:solidFill>
+                          <a:latin typeface="Segoe UI"/>
+                        </a:defRPr>
+                      </a:pPr>
+                      <a:r>
+                        <a:t>Packages all 4 layers into standardized containers for single-command deployment. Built as a production-style system, not just a static demo.</a:t>
                       </a:r>
                     </a:p>
                   </a:txBody>

</xml_diff>